<commit_message>
Add new PNG images to the stamp folder
- Added "4.川浪.png" and "5.時尾.png" to the static image stamps directory.
</commit_message>
<xml_diff>
--- a/static/img/stamp/stamp.pptx
+++ b/static/img/stamp/stamp.pptx
@@ -259,7 +259,7 @@
           <a:p>
             <a:fld id="{37C43073-F3F6-448C-9B41-23C423DD3076}" type="datetimeFigureOut">
               <a:rPr kumimoji="1" lang="ja-JP" altLang="en-US" smtClean="0"/>
-              <a:t>2024/10/25</a:t>
+              <a:t>2026/5/27</a:t>
             </a:fld>
             <a:endParaRPr kumimoji="1" lang="ja-JP" altLang="en-US"/>
           </a:p>
@@ -489,7 +489,7 @@
           <a:p>
             <a:fld id="{37C43073-F3F6-448C-9B41-23C423DD3076}" type="datetimeFigureOut">
               <a:rPr kumimoji="1" lang="ja-JP" altLang="en-US" smtClean="0"/>
-              <a:t>2024/10/25</a:t>
+              <a:t>2026/5/27</a:t>
             </a:fld>
             <a:endParaRPr kumimoji="1" lang="ja-JP" altLang="en-US"/>
           </a:p>
@@ -729,7 +729,7 @@
           <a:p>
             <a:fld id="{37C43073-F3F6-448C-9B41-23C423DD3076}" type="datetimeFigureOut">
               <a:rPr kumimoji="1" lang="ja-JP" altLang="en-US" smtClean="0"/>
-              <a:t>2024/10/25</a:t>
+              <a:t>2026/5/27</a:t>
             </a:fld>
             <a:endParaRPr kumimoji="1" lang="ja-JP" altLang="en-US"/>
           </a:p>
@@ -959,7 +959,7 @@
           <a:p>
             <a:fld id="{37C43073-F3F6-448C-9B41-23C423DD3076}" type="datetimeFigureOut">
               <a:rPr kumimoji="1" lang="ja-JP" altLang="en-US" smtClean="0"/>
-              <a:t>2024/10/25</a:t>
+              <a:t>2026/5/27</a:t>
             </a:fld>
             <a:endParaRPr kumimoji="1" lang="ja-JP" altLang="en-US"/>
           </a:p>
@@ -1234,7 +1234,7 @@
           <a:p>
             <a:fld id="{37C43073-F3F6-448C-9B41-23C423DD3076}" type="datetimeFigureOut">
               <a:rPr kumimoji="1" lang="ja-JP" altLang="en-US" smtClean="0"/>
-              <a:t>2024/10/25</a:t>
+              <a:t>2026/5/27</a:t>
             </a:fld>
             <a:endParaRPr kumimoji="1" lang="ja-JP" altLang="en-US"/>
           </a:p>
@@ -1563,7 +1563,7 @@
           <a:p>
             <a:fld id="{37C43073-F3F6-448C-9B41-23C423DD3076}" type="datetimeFigureOut">
               <a:rPr kumimoji="1" lang="ja-JP" altLang="en-US" smtClean="0"/>
-              <a:t>2024/10/25</a:t>
+              <a:t>2026/5/27</a:t>
             </a:fld>
             <a:endParaRPr kumimoji="1" lang="ja-JP" altLang="en-US"/>
           </a:p>
@@ -2039,7 +2039,7 @@
           <a:p>
             <a:fld id="{37C43073-F3F6-448C-9B41-23C423DD3076}" type="datetimeFigureOut">
               <a:rPr kumimoji="1" lang="ja-JP" altLang="en-US" smtClean="0"/>
-              <a:t>2024/10/25</a:t>
+              <a:t>2026/5/27</a:t>
             </a:fld>
             <a:endParaRPr kumimoji="1" lang="ja-JP" altLang="en-US"/>
           </a:p>
@@ -2180,7 +2180,7 @@
           <a:p>
             <a:fld id="{37C43073-F3F6-448C-9B41-23C423DD3076}" type="datetimeFigureOut">
               <a:rPr kumimoji="1" lang="ja-JP" altLang="en-US" smtClean="0"/>
-              <a:t>2024/10/25</a:t>
+              <a:t>2026/5/27</a:t>
             </a:fld>
             <a:endParaRPr kumimoji="1" lang="ja-JP" altLang="en-US"/>
           </a:p>
@@ -2293,7 +2293,7 @@
           <a:p>
             <a:fld id="{37C43073-F3F6-448C-9B41-23C423DD3076}" type="datetimeFigureOut">
               <a:rPr kumimoji="1" lang="ja-JP" altLang="en-US" smtClean="0"/>
-              <a:t>2024/10/25</a:t>
+              <a:t>2026/5/27</a:t>
             </a:fld>
             <a:endParaRPr kumimoji="1" lang="ja-JP" altLang="en-US"/>
           </a:p>
@@ -2636,7 +2636,7 @@
           <a:p>
             <a:fld id="{37C43073-F3F6-448C-9B41-23C423DD3076}" type="datetimeFigureOut">
               <a:rPr kumimoji="1" lang="ja-JP" altLang="en-US" smtClean="0"/>
-              <a:t>2024/10/25</a:t>
+              <a:t>2026/5/27</a:t>
             </a:fld>
             <a:endParaRPr kumimoji="1" lang="ja-JP" altLang="en-US"/>
           </a:p>
@@ -2924,7 +2924,7 @@
           <a:p>
             <a:fld id="{37C43073-F3F6-448C-9B41-23C423DD3076}" type="datetimeFigureOut">
               <a:rPr kumimoji="1" lang="ja-JP" altLang="en-US" smtClean="0"/>
-              <a:t>2024/10/25</a:t>
+              <a:t>2026/5/27</a:t>
             </a:fld>
             <a:endParaRPr kumimoji="1" lang="ja-JP" altLang="en-US"/>
           </a:p>
@@ -3197,7 +3197,7 @@
           <a:p>
             <a:fld id="{37C43073-F3F6-448C-9B41-23C423DD3076}" type="datetimeFigureOut">
               <a:rPr kumimoji="1" lang="ja-JP" altLang="en-US" smtClean="0"/>
-              <a:t>2024/10/25</a:t>
+              <a:t>2026/5/27</a:t>
             </a:fld>
             <a:endParaRPr kumimoji="1" lang="ja-JP" altLang="en-US"/>
           </a:p>
@@ -3628,7 +3628,7 @@
         </p:nvGrpSpPr>
         <p:grpSpPr>
           <a:xfrm>
-            <a:off x="7891964" y="3074944"/>
+            <a:off x="7970986" y="1031656"/>
             <a:ext cx="708112" cy="708112"/>
             <a:chOff x="649942" y="764723"/>
             <a:chExt cx="708112" cy="708112"/>
@@ -3684,7 +3684,10 @@
             <a:lstStyle/>
             <a:p>
               <a:pPr algn="ctr"/>
-              <a:endParaRPr kumimoji="1" lang="ja-JP" altLang="en-US"/>
+              <a:endParaRPr kumimoji="1" lang="ja-JP" altLang="en-US" sz="2400" b="1">
+                <a:latin typeface="ＭＳ Ｐ明朝" panose="02020600040205080304" pitchFamily="18" charset="-128"/>
+                <a:ea typeface="ＭＳ Ｐ明朝" panose="02020600040205080304" pitchFamily="18" charset="-128"/>
+              </a:endParaRPr>
             </a:p>
           </p:txBody>
         </p:sp>
@@ -3702,8 +3705,8 @@
           </p:nvSpPr>
           <p:spPr>
             <a:xfrm>
-              <a:off x="809073" y="826391"/>
-              <a:ext cx="389850" cy="584775"/>
+              <a:off x="782624" y="764836"/>
+              <a:ext cx="442749" cy="707886"/>
             </a:xfrm>
             <a:prstGeom prst="rect">
               <a:avLst/>
@@ -3718,41 +3721,41 @@
             <a:p>
               <a:pPr algn="ctr"/>
               <a:r>
-                <a:rPr lang="ja-JP" altLang="en-US" sz="1600" dirty="0">
+                <a:rPr lang="ja-JP" altLang="en-US" sz="2000" b="1" dirty="0">
                   <a:solidFill>
                     <a:srgbClr val="FF0000"/>
                   </a:solidFill>
-                  <a:latin typeface="HG正楷書体-PRO" panose="03000600000000000000" pitchFamily="66" charset="-128"/>
-                  <a:ea typeface="HG正楷書体-PRO" panose="03000600000000000000" pitchFamily="66" charset="-128"/>
+                  <a:latin typeface="ＭＳ Ｐ明朝" panose="02020600040205080304" pitchFamily="18" charset="-128"/>
+                  <a:ea typeface="ＭＳ Ｐ明朝" panose="02020600040205080304" pitchFamily="18" charset="-128"/>
                 </a:rPr>
                 <a:t>宮</a:t>
               </a:r>
-              <a:endParaRPr lang="en-US" altLang="ja-JP" sz="1600" dirty="0">
+              <a:endParaRPr lang="en-US" altLang="ja-JP" sz="2000" b="1" dirty="0">
                 <a:solidFill>
                   <a:srgbClr val="FF0000"/>
                 </a:solidFill>
-                <a:latin typeface="HG正楷書体-PRO" panose="03000600000000000000" pitchFamily="66" charset="-128"/>
-                <a:ea typeface="HG正楷書体-PRO" panose="03000600000000000000" pitchFamily="66" charset="-128"/>
+                <a:latin typeface="ＭＳ Ｐ明朝" panose="02020600040205080304" pitchFamily="18" charset="-128"/>
+                <a:ea typeface="ＭＳ Ｐ明朝" panose="02020600040205080304" pitchFamily="18" charset="-128"/>
               </a:endParaRPr>
             </a:p>
             <a:p>
               <a:pPr algn="ctr"/>
               <a:r>
-                <a:rPr lang="ja-JP" altLang="en-US" sz="1600" dirty="0">
+                <a:rPr lang="ja-JP" altLang="en-US" sz="2000" b="1" dirty="0">
                   <a:solidFill>
                     <a:srgbClr val="FF0000"/>
                   </a:solidFill>
-                  <a:latin typeface="HG正楷書体-PRO" panose="03000600000000000000" pitchFamily="66" charset="-128"/>
-                  <a:ea typeface="HG正楷書体-PRO" panose="03000600000000000000" pitchFamily="66" charset="-128"/>
+                  <a:latin typeface="ＭＳ Ｐ明朝" panose="02020600040205080304" pitchFamily="18" charset="-128"/>
+                  <a:ea typeface="ＭＳ Ｐ明朝" panose="02020600040205080304" pitchFamily="18" charset="-128"/>
                 </a:rPr>
                 <a:t>井</a:t>
               </a:r>
-              <a:endParaRPr kumimoji="1" lang="ja-JP" altLang="en-US" sz="1600" dirty="0">
+              <a:endParaRPr kumimoji="1" lang="ja-JP" altLang="en-US" sz="2000" b="1" dirty="0">
                 <a:solidFill>
                   <a:srgbClr val="FF0000"/>
                 </a:solidFill>
-                <a:latin typeface="HG正楷書体-PRO" panose="03000600000000000000" pitchFamily="66" charset="-128"/>
-                <a:ea typeface="HG正楷書体-PRO" panose="03000600000000000000" pitchFamily="66" charset="-128"/>
+                <a:latin typeface="ＭＳ Ｐ明朝" panose="02020600040205080304" pitchFamily="18" charset="-128"/>
+                <a:ea typeface="ＭＳ Ｐ明朝" panose="02020600040205080304" pitchFamily="18" charset="-128"/>
               </a:endParaRPr>
             </a:p>
           </p:txBody>
@@ -3772,7 +3775,7 @@
         </p:nvGrpSpPr>
         <p:grpSpPr>
           <a:xfrm>
-            <a:off x="2158580" y="3074944"/>
+            <a:off x="2237602" y="1031656"/>
             <a:ext cx="708112" cy="708112"/>
             <a:chOff x="649942" y="764723"/>
             <a:chExt cx="708112" cy="708112"/>
@@ -3828,7 +3831,10 @@
             <a:lstStyle/>
             <a:p>
               <a:pPr algn="ctr"/>
-              <a:endParaRPr kumimoji="1" lang="ja-JP" altLang="en-US"/>
+              <a:endParaRPr kumimoji="1" lang="ja-JP" altLang="en-US" sz="2400" b="1">
+                <a:latin typeface="ＭＳ Ｐ明朝" panose="02020600040205080304" pitchFamily="18" charset="-128"/>
+                <a:ea typeface="ＭＳ Ｐ明朝" panose="02020600040205080304" pitchFamily="18" charset="-128"/>
+              </a:endParaRPr>
             </a:p>
           </p:txBody>
         </p:sp>
@@ -3846,8 +3852,8 @@
           </p:nvSpPr>
           <p:spPr>
             <a:xfrm>
-              <a:off x="809073" y="826391"/>
-              <a:ext cx="389850" cy="584775"/>
+              <a:off x="782624" y="764836"/>
+              <a:ext cx="442749" cy="707886"/>
             </a:xfrm>
             <a:prstGeom prst="rect">
               <a:avLst/>
@@ -3862,32 +3868,32 @@
             <a:p>
               <a:pPr algn="ctr"/>
               <a:r>
-                <a:rPr kumimoji="1" lang="ja-JP" altLang="en-US" sz="1600" dirty="0">
+                <a:rPr kumimoji="1" lang="ja-JP" altLang="en-US" sz="2000" b="1" dirty="0">
                   <a:solidFill>
                     <a:srgbClr val="FF0000"/>
                   </a:solidFill>
-                  <a:latin typeface="HG正楷書体-PRO" panose="03000600000000000000" pitchFamily="66" charset="-128"/>
-                  <a:ea typeface="HG正楷書体-PRO" panose="03000600000000000000" pitchFamily="66" charset="-128"/>
+                  <a:latin typeface="ＭＳ Ｐ明朝" panose="02020600040205080304" pitchFamily="18" charset="-128"/>
+                  <a:ea typeface="ＭＳ Ｐ明朝" panose="02020600040205080304" pitchFamily="18" charset="-128"/>
                 </a:rPr>
                 <a:t>山</a:t>
               </a:r>
-              <a:endParaRPr kumimoji="1" lang="en-US" altLang="ja-JP" sz="1600" dirty="0">
+              <a:endParaRPr kumimoji="1" lang="en-US" altLang="ja-JP" sz="2000" b="1" dirty="0">
                 <a:solidFill>
                   <a:srgbClr val="FF0000"/>
                 </a:solidFill>
-                <a:latin typeface="HG正楷書体-PRO" panose="03000600000000000000" pitchFamily="66" charset="-128"/>
-                <a:ea typeface="HG正楷書体-PRO" panose="03000600000000000000" pitchFamily="66" charset="-128"/>
+                <a:latin typeface="ＭＳ Ｐ明朝" panose="02020600040205080304" pitchFamily="18" charset="-128"/>
+                <a:ea typeface="ＭＳ Ｐ明朝" panose="02020600040205080304" pitchFamily="18" charset="-128"/>
               </a:endParaRPr>
             </a:p>
             <a:p>
               <a:pPr algn="ctr"/>
               <a:r>
-                <a:rPr kumimoji="1" lang="ja-JP" altLang="en-US" sz="1600" dirty="0">
+                <a:rPr kumimoji="1" lang="ja-JP" altLang="en-US" sz="2000" b="1" dirty="0">
                   <a:solidFill>
                     <a:srgbClr val="FF0000"/>
                   </a:solidFill>
-                  <a:latin typeface="HG正楷書体-PRO" panose="03000600000000000000" pitchFamily="66" charset="-128"/>
-                  <a:ea typeface="HG正楷書体-PRO" panose="03000600000000000000" pitchFamily="66" charset="-128"/>
+                  <a:latin typeface="ＭＳ Ｐ明朝" panose="02020600040205080304" pitchFamily="18" charset="-128"/>
+                  <a:ea typeface="ＭＳ Ｐ明朝" panose="02020600040205080304" pitchFamily="18" charset="-128"/>
                 </a:rPr>
                 <a:t>本</a:t>
               </a:r>
@@ -3909,7 +3915,7 @@
         </p:nvGrpSpPr>
         <p:grpSpPr>
           <a:xfrm>
-            <a:off x="3591926" y="3074944"/>
+            <a:off x="3670948" y="1031656"/>
             <a:ext cx="708112" cy="708112"/>
             <a:chOff x="649942" y="764723"/>
             <a:chExt cx="708112" cy="708112"/>
@@ -3965,7 +3971,10 @@
             <a:lstStyle/>
             <a:p>
               <a:pPr algn="ctr"/>
-              <a:endParaRPr kumimoji="1" lang="ja-JP" altLang="en-US"/>
+              <a:endParaRPr kumimoji="1" lang="ja-JP" altLang="en-US" sz="2400" b="1">
+                <a:latin typeface="ＭＳ Ｐ明朝" panose="02020600040205080304" pitchFamily="18" charset="-128"/>
+                <a:ea typeface="ＭＳ Ｐ明朝" panose="02020600040205080304" pitchFamily="18" charset="-128"/>
+              </a:endParaRPr>
             </a:p>
           </p:txBody>
         </p:sp>
@@ -3983,8 +3992,8 @@
           </p:nvSpPr>
           <p:spPr>
             <a:xfrm>
-              <a:off x="809073" y="826391"/>
-              <a:ext cx="389850" cy="584775"/>
+              <a:off x="782624" y="764836"/>
+              <a:ext cx="442749" cy="707886"/>
             </a:xfrm>
             <a:prstGeom prst="rect">
               <a:avLst/>
@@ -3999,32 +4008,32 @@
             <a:p>
               <a:pPr algn="ctr"/>
               <a:r>
-                <a:rPr kumimoji="1" lang="ja-JP" altLang="en-US" sz="1600" dirty="0">
+                <a:rPr kumimoji="1" lang="ja-JP" altLang="en-US" sz="2000" b="1" dirty="0">
                   <a:solidFill>
                     <a:srgbClr val="FF0000"/>
                   </a:solidFill>
-                  <a:latin typeface="HG正楷書体-PRO" panose="03000600000000000000" pitchFamily="66" charset="-128"/>
-                  <a:ea typeface="HG正楷書体-PRO" panose="03000600000000000000" pitchFamily="66" charset="-128"/>
+                  <a:latin typeface="ＭＳ Ｐ明朝" panose="02020600040205080304" pitchFamily="18" charset="-128"/>
+                  <a:ea typeface="ＭＳ Ｐ明朝" panose="02020600040205080304" pitchFamily="18" charset="-128"/>
                 </a:rPr>
                 <a:t>藤</a:t>
               </a:r>
-              <a:endParaRPr kumimoji="1" lang="en-US" altLang="ja-JP" sz="1600" dirty="0">
+              <a:endParaRPr kumimoji="1" lang="en-US" altLang="ja-JP" sz="2000" b="1" dirty="0">
                 <a:solidFill>
                   <a:srgbClr val="FF0000"/>
                 </a:solidFill>
-                <a:latin typeface="HG正楷書体-PRO" panose="03000600000000000000" pitchFamily="66" charset="-128"/>
-                <a:ea typeface="HG正楷書体-PRO" panose="03000600000000000000" pitchFamily="66" charset="-128"/>
+                <a:latin typeface="ＭＳ Ｐ明朝" panose="02020600040205080304" pitchFamily="18" charset="-128"/>
+                <a:ea typeface="ＭＳ Ｐ明朝" panose="02020600040205080304" pitchFamily="18" charset="-128"/>
               </a:endParaRPr>
             </a:p>
             <a:p>
               <a:pPr algn="ctr"/>
               <a:r>
-                <a:rPr kumimoji="1" lang="ja-JP" altLang="en-US" sz="1600" dirty="0">
+                <a:rPr kumimoji="1" lang="ja-JP" altLang="en-US" sz="2000" b="1" dirty="0">
                   <a:solidFill>
                     <a:srgbClr val="FF0000"/>
                   </a:solidFill>
-                  <a:latin typeface="HG正楷書体-PRO" panose="03000600000000000000" pitchFamily="66" charset="-128"/>
-                  <a:ea typeface="HG正楷書体-PRO" panose="03000600000000000000" pitchFamily="66" charset="-128"/>
+                  <a:latin typeface="ＭＳ Ｐ明朝" panose="02020600040205080304" pitchFamily="18" charset="-128"/>
+                  <a:ea typeface="ＭＳ Ｐ明朝" panose="02020600040205080304" pitchFamily="18" charset="-128"/>
                 </a:rPr>
                 <a:t>原</a:t>
               </a:r>
@@ -4046,7 +4055,7 @@
         </p:nvGrpSpPr>
         <p:grpSpPr>
           <a:xfrm>
-            <a:off x="5025272" y="3074944"/>
+            <a:off x="5104294" y="1031656"/>
             <a:ext cx="708112" cy="708112"/>
             <a:chOff x="649942" y="764723"/>
             <a:chExt cx="708112" cy="708112"/>
@@ -4102,7 +4111,10 @@
             <a:lstStyle/>
             <a:p>
               <a:pPr algn="ctr"/>
-              <a:endParaRPr kumimoji="1" lang="ja-JP" altLang="en-US"/>
+              <a:endParaRPr kumimoji="1" lang="ja-JP" altLang="en-US" sz="2400" b="1">
+                <a:latin typeface="ＭＳ Ｐ明朝" panose="02020600040205080304" pitchFamily="18" charset="-128"/>
+                <a:ea typeface="ＭＳ Ｐ明朝" panose="02020600040205080304" pitchFamily="18" charset="-128"/>
+              </a:endParaRPr>
             </a:p>
           </p:txBody>
         </p:sp>
@@ -4120,8 +4132,8 @@
           </p:nvSpPr>
           <p:spPr>
             <a:xfrm>
-              <a:off x="809073" y="826391"/>
-              <a:ext cx="389850" cy="584775"/>
+              <a:off x="782624" y="764836"/>
+              <a:ext cx="442749" cy="707886"/>
             </a:xfrm>
             <a:prstGeom prst="rect">
               <a:avLst/>
@@ -4136,32 +4148,32 @@
             <a:p>
               <a:pPr algn="ctr"/>
               <a:r>
-                <a:rPr kumimoji="1" lang="ja-JP" altLang="en-US" sz="1600" dirty="0">
+                <a:rPr kumimoji="1" lang="ja-JP" altLang="en-US" sz="2000" b="1" dirty="0">
                   <a:solidFill>
                     <a:srgbClr val="FF0000"/>
                   </a:solidFill>
-                  <a:latin typeface="HG正楷書体-PRO" panose="03000600000000000000" pitchFamily="66" charset="-128"/>
-                  <a:ea typeface="HG正楷書体-PRO" panose="03000600000000000000" pitchFamily="66" charset="-128"/>
+                  <a:latin typeface="ＭＳ Ｐ明朝" panose="02020600040205080304" pitchFamily="18" charset="-128"/>
+                  <a:ea typeface="ＭＳ Ｐ明朝" panose="02020600040205080304" pitchFamily="18" charset="-128"/>
                 </a:rPr>
                 <a:t>川</a:t>
               </a:r>
-              <a:endParaRPr kumimoji="1" lang="en-US" altLang="ja-JP" sz="1600" dirty="0">
+              <a:endParaRPr kumimoji="1" lang="en-US" altLang="ja-JP" sz="2000" b="1" dirty="0">
                 <a:solidFill>
                   <a:srgbClr val="FF0000"/>
                 </a:solidFill>
-                <a:latin typeface="HG正楷書体-PRO" panose="03000600000000000000" pitchFamily="66" charset="-128"/>
-                <a:ea typeface="HG正楷書体-PRO" panose="03000600000000000000" pitchFamily="66" charset="-128"/>
+                <a:latin typeface="ＭＳ Ｐ明朝" panose="02020600040205080304" pitchFamily="18" charset="-128"/>
+                <a:ea typeface="ＭＳ Ｐ明朝" panose="02020600040205080304" pitchFamily="18" charset="-128"/>
               </a:endParaRPr>
             </a:p>
             <a:p>
               <a:pPr algn="ctr"/>
               <a:r>
-                <a:rPr kumimoji="1" lang="ja-JP" altLang="en-US" sz="1600" dirty="0">
+                <a:rPr kumimoji="1" lang="ja-JP" altLang="en-US" sz="2000" b="1" dirty="0">
                   <a:solidFill>
                     <a:srgbClr val="FF0000"/>
                   </a:solidFill>
-                  <a:latin typeface="HG正楷書体-PRO" panose="03000600000000000000" pitchFamily="66" charset="-128"/>
-                  <a:ea typeface="HG正楷書体-PRO" panose="03000600000000000000" pitchFamily="66" charset="-128"/>
+                  <a:latin typeface="ＭＳ Ｐ明朝" panose="02020600040205080304" pitchFamily="18" charset="-128"/>
+                  <a:ea typeface="ＭＳ Ｐ明朝" panose="02020600040205080304" pitchFamily="18" charset="-128"/>
                 </a:rPr>
                 <a:t>浪</a:t>
               </a:r>
@@ -4183,8 +4195,8 @@
         </p:nvGrpSpPr>
         <p:grpSpPr>
           <a:xfrm>
-            <a:off x="725234" y="3074944"/>
-            <a:ext cx="708112" cy="708112"/>
+            <a:off x="804256" y="1031656"/>
+            <a:ext cx="708111" cy="708112"/>
             <a:chOff x="649942" y="764723"/>
             <a:chExt cx="708112" cy="708112"/>
           </a:xfrm>
@@ -4239,7 +4251,10 @@
             <a:lstStyle/>
             <a:p>
               <a:pPr algn="ctr"/>
-              <a:endParaRPr kumimoji="1" lang="ja-JP" altLang="en-US"/>
+              <a:endParaRPr kumimoji="1" lang="ja-JP" altLang="en-US" sz="2400" b="1">
+                <a:latin typeface="ＭＳ Ｐ明朝" panose="02020600040205080304" pitchFamily="18" charset="-128"/>
+                <a:ea typeface="ＭＳ Ｐ明朝" panose="02020600040205080304" pitchFamily="18" charset="-128"/>
+              </a:endParaRPr>
             </a:p>
           </p:txBody>
         </p:sp>
@@ -4257,8 +4272,8 @@
           </p:nvSpPr>
           <p:spPr>
             <a:xfrm>
-              <a:off x="809073" y="826391"/>
-              <a:ext cx="389850" cy="584775"/>
+              <a:off x="782623" y="764836"/>
+              <a:ext cx="442750" cy="707886"/>
             </a:xfrm>
             <a:prstGeom prst="rect">
               <a:avLst/>
@@ -4273,41 +4288,41 @@
             <a:p>
               <a:pPr algn="ctr"/>
               <a:r>
-                <a:rPr lang="ja-JP" altLang="en-US" sz="1600" dirty="0">
+                <a:rPr lang="ja-JP" altLang="en-US" sz="2000" b="1" dirty="0">
                   <a:solidFill>
                     <a:srgbClr val="FF0000"/>
                   </a:solidFill>
-                  <a:latin typeface="HG正楷書体-PRO" panose="03000600000000000000" pitchFamily="66" charset="-128"/>
-                  <a:ea typeface="HG正楷書体-PRO" panose="03000600000000000000" pitchFamily="66" charset="-128"/>
+                  <a:latin typeface="ＭＳ Ｐ明朝" panose="02020600040205080304" pitchFamily="18" charset="-128"/>
+                  <a:ea typeface="ＭＳ Ｐ明朝" panose="02020600040205080304" pitchFamily="18" charset="-128"/>
                 </a:rPr>
                 <a:t>宮</a:t>
               </a:r>
-              <a:endParaRPr lang="en-US" altLang="ja-JP" sz="1600" dirty="0">
+              <a:endParaRPr lang="en-US" altLang="ja-JP" sz="2000" b="1" dirty="0">
                 <a:solidFill>
                   <a:srgbClr val="FF0000"/>
                 </a:solidFill>
-                <a:latin typeface="HG正楷書体-PRO" panose="03000600000000000000" pitchFamily="66" charset="-128"/>
-                <a:ea typeface="HG正楷書体-PRO" panose="03000600000000000000" pitchFamily="66" charset="-128"/>
+                <a:latin typeface="ＭＳ Ｐ明朝" panose="02020600040205080304" pitchFamily="18" charset="-128"/>
+                <a:ea typeface="ＭＳ Ｐ明朝" panose="02020600040205080304" pitchFamily="18" charset="-128"/>
               </a:endParaRPr>
             </a:p>
             <a:p>
               <a:pPr algn="ctr"/>
               <a:r>
-                <a:rPr lang="ja-JP" altLang="en-US" sz="1600" dirty="0">
+                <a:rPr lang="ja-JP" altLang="en-US" sz="2000" b="1" dirty="0">
                   <a:solidFill>
                     <a:srgbClr val="FF0000"/>
                   </a:solidFill>
-                  <a:latin typeface="HG正楷書体-PRO" panose="03000600000000000000" pitchFamily="66" charset="-128"/>
-                  <a:ea typeface="HG正楷書体-PRO" panose="03000600000000000000" pitchFamily="66" charset="-128"/>
+                  <a:latin typeface="ＭＳ Ｐ明朝" panose="02020600040205080304" pitchFamily="18" charset="-128"/>
+                  <a:ea typeface="ＭＳ Ｐ明朝" panose="02020600040205080304" pitchFamily="18" charset="-128"/>
                 </a:rPr>
                 <a:t>井</a:t>
               </a:r>
-              <a:endParaRPr kumimoji="1" lang="ja-JP" altLang="en-US" sz="1600" dirty="0">
+              <a:endParaRPr kumimoji="1" lang="ja-JP" altLang="en-US" sz="2000" b="1" dirty="0">
                 <a:solidFill>
                   <a:srgbClr val="FF0000"/>
                 </a:solidFill>
-                <a:latin typeface="HG正楷書体-PRO" panose="03000600000000000000" pitchFamily="66" charset="-128"/>
-                <a:ea typeface="HG正楷書体-PRO" panose="03000600000000000000" pitchFamily="66" charset="-128"/>
+                <a:latin typeface="ＭＳ Ｐ明朝" panose="02020600040205080304" pitchFamily="18" charset="-128"/>
+                <a:ea typeface="ＭＳ Ｐ明朝" panose="02020600040205080304" pitchFamily="18" charset="-128"/>
               </a:endParaRPr>
             </a:p>
           </p:txBody>
@@ -4327,10 +4342,10 @@
         </p:nvGrpSpPr>
         <p:grpSpPr>
           <a:xfrm>
-            <a:off x="10758656" y="3074944"/>
-            <a:ext cx="708112" cy="708112"/>
-            <a:chOff x="649942" y="764723"/>
-            <a:chExt cx="708112" cy="708112"/>
+            <a:off x="10837678" y="970214"/>
+            <a:ext cx="708112" cy="830997"/>
+            <a:chOff x="649942" y="703281"/>
+            <a:chExt cx="708112" cy="830997"/>
           </a:xfrm>
         </p:grpSpPr>
         <p:sp>
@@ -4383,7 +4398,10 @@
             <a:lstStyle/>
             <a:p>
               <a:pPr algn="ctr"/>
-              <a:endParaRPr kumimoji="1" lang="ja-JP" altLang="en-US"/>
+              <a:endParaRPr kumimoji="1" lang="ja-JP" altLang="en-US" sz="2800" b="1">
+                <a:latin typeface="ＭＳ Ｐ明朝" panose="02020600040205080304" pitchFamily="18" charset="-128"/>
+                <a:ea typeface="ＭＳ Ｐ明朝" panose="02020600040205080304" pitchFamily="18" charset="-128"/>
+              </a:endParaRPr>
             </a:p>
           </p:txBody>
         </p:sp>
@@ -4401,8 +4419,8 @@
           </p:nvSpPr>
           <p:spPr>
             <a:xfrm>
-              <a:off x="809073" y="826391"/>
-              <a:ext cx="389850" cy="584775"/>
+              <a:off x="757777" y="703281"/>
+              <a:ext cx="492443" cy="830997"/>
             </a:xfrm>
             <a:prstGeom prst="rect">
               <a:avLst/>
@@ -4417,41 +4435,41 @@
             <a:p>
               <a:pPr algn="ctr"/>
               <a:r>
-                <a:rPr lang="ja-JP" altLang="en-US" sz="1600" dirty="0">
+                <a:rPr lang="ja-JP" altLang="en-US" sz="2400" b="1" dirty="0">
                   <a:solidFill>
                     <a:srgbClr val="FF0000"/>
                   </a:solidFill>
-                  <a:latin typeface="HG正楷書体-PRO" panose="03000600000000000000" pitchFamily="66" charset="-128"/>
-                  <a:ea typeface="HG正楷書体-PRO" panose="03000600000000000000" pitchFamily="66" charset="-128"/>
+                  <a:latin typeface="ＭＳ Ｐ明朝" panose="02020600040205080304" pitchFamily="18" charset="-128"/>
+                  <a:ea typeface="ＭＳ Ｐ明朝" panose="02020600040205080304" pitchFamily="18" charset="-128"/>
                 </a:rPr>
                 <a:t>宮</a:t>
               </a:r>
-              <a:endParaRPr lang="en-US" altLang="ja-JP" sz="1600" dirty="0">
+              <a:endParaRPr lang="en-US" altLang="ja-JP" sz="2400" b="1" dirty="0">
                 <a:solidFill>
                   <a:srgbClr val="FF0000"/>
                 </a:solidFill>
-                <a:latin typeface="HG正楷書体-PRO" panose="03000600000000000000" pitchFamily="66" charset="-128"/>
-                <a:ea typeface="HG正楷書体-PRO" panose="03000600000000000000" pitchFamily="66" charset="-128"/>
+                <a:latin typeface="ＭＳ Ｐ明朝" panose="02020600040205080304" pitchFamily="18" charset="-128"/>
+                <a:ea typeface="ＭＳ Ｐ明朝" panose="02020600040205080304" pitchFamily="18" charset="-128"/>
               </a:endParaRPr>
             </a:p>
             <a:p>
               <a:pPr algn="ctr"/>
               <a:r>
-                <a:rPr lang="ja-JP" altLang="en-US" sz="1600" dirty="0">
+                <a:rPr lang="ja-JP" altLang="en-US" sz="2400" b="1" dirty="0">
                   <a:solidFill>
                     <a:srgbClr val="FF0000"/>
                   </a:solidFill>
-                  <a:latin typeface="HG正楷書体-PRO" panose="03000600000000000000" pitchFamily="66" charset="-128"/>
-                  <a:ea typeface="HG正楷書体-PRO" panose="03000600000000000000" pitchFamily="66" charset="-128"/>
+                  <a:latin typeface="ＭＳ Ｐ明朝" panose="02020600040205080304" pitchFamily="18" charset="-128"/>
+                  <a:ea typeface="ＭＳ Ｐ明朝" panose="02020600040205080304" pitchFamily="18" charset="-128"/>
                 </a:rPr>
                 <a:t>井</a:t>
               </a:r>
-              <a:endParaRPr kumimoji="1" lang="ja-JP" altLang="en-US" sz="1600" dirty="0">
+              <a:endParaRPr kumimoji="1" lang="ja-JP" altLang="en-US" sz="2400" b="1" dirty="0">
                 <a:solidFill>
                   <a:srgbClr val="FF0000"/>
                 </a:solidFill>
-                <a:latin typeface="HG正楷書体-PRO" panose="03000600000000000000" pitchFamily="66" charset="-128"/>
-                <a:ea typeface="HG正楷書体-PRO" panose="03000600000000000000" pitchFamily="66" charset="-128"/>
+                <a:latin typeface="ＭＳ Ｐ明朝" panose="02020600040205080304" pitchFamily="18" charset="-128"/>
+                <a:ea typeface="ＭＳ Ｐ明朝" panose="02020600040205080304" pitchFamily="18" charset="-128"/>
               </a:endParaRPr>
             </a:p>
           </p:txBody>
@@ -4471,7 +4489,7 @@
         </p:nvGrpSpPr>
         <p:grpSpPr>
           <a:xfrm>
-            <a:off x="9325310" y="3074944"/>
+            <a:off x="9404332" y="1031656"/>
             <a:ext cx="708112" cy="708112"/>
             <a:chOff x="649942" y="764723"/>
             <a:chExt cx="708112" cy="708112"/>
@@ -4527,7 +4545,10 @@
             <a:lstStyle/>
             <a:p>
               <a:pPr algn="ctr"/>
-              <a:endParaRPr kumimoji="1" lang="ja-JP" altLang="en-US"/>
+              <a:endParaRPr kumimoji="1" lang="ja-JP" altLang="en-US" sz="2400" b="1">
+                <a:latin typeface="ＭＳ Ｐ明朝" panose="02020600040205080304" pitchFamily="18" charset="-128"/>
+                <a:ea typeface="ＭＳ Ｐ明朝" panose="02020600040205080304" pitchFamily="18" charset="-128"/>
+              </a:endParaRPr>
             </a:p>
           </p:txBody>
         </p:sp>
@@ -4545,8 +4566,8 @@
           </p:nvSpPr>
           <p:spPr>
             <a:xfrm>
-              <a:off x="809073" y="826391"/>
-              <a:ext cx="389850" cy="584775"/>
+              <a:off x="782624" y="764836"/>
+              <a:ext cx="442749" cy="707886"/>
             </a:xfrm>
             <a:prstGeom prst="rect">
               <a:avLst/>
@@ -4561,46 +4582,105 @@
             <a:p>
               <a:pPr algn="ctr"/>
               <a:r>
-                <a:rPr lang="ja-JP" altLang="en-US" sz="1600" dirty="0">
+                <a:rPr lang="ja-JP" altLang="en-US" sz="2000" b="1" dirty="0">
                   <a:solidFill>
                     <a:srgbClr val="FF0000"/>
                   </a:solidFill>
-                  <a:latin typeface="HG正楷書体-PRO" panose="03000600000000000000" pitchFamily="66" charset="-128"/>
-                  <a:ea typeface="HG正楷書体-PRO" panose="03000600000000000000" pitchFamily="66" charset="-128"/>
+                  <a:latin typeface="ＭＳ Ｐ明朝" panose="02020600040205080304" pitchFamily="18" charset="-128"/>
+                  <a:ea typeface="ＭＳ Ｐ明朝" panose="02020600040205080304" pitchFamily="18" charset="-128"/>
                 </a:rPr>
                 <a:t>宮</a:t>
               </a:r>
-              <a:endParaRPr lang="en-US" altLang="ja-JP" sz="1600" dirty="0">
+              <a:endParaRPr lang="en-US" altLang="ja-JP" sz="2000" b="1" dirty="0">
                 <a:solidFill>
                   <a:srgbClr val="FF0000"/>
                 </a:solidFill>
-                <a:latin typeface="HG正楷書体-PRO" panose="03000600000000000000" pitchFamily="66" charset="-128"/>
-                <a:ea typeface="HG正楷書体-PRO" panose="03000600000000000000" pitchFamily="66" charset="-128"/>
+                <a:latin typeface="ＭＳ Ｐ明朝" panose="02020600040205080304" pitchFamily="18" charset="-128"/>
+                <a:ea typeface="ＭＳ Ｐ明朝" panose="02020600040205080304" pitchFamily="18" charset="-128"/>
               </a:endParaRPr>
             </a:p>
             <a:p>
               <a:pPr algn="ctr"/>
               <a:r>
-                <a:rPr lang="ja-JP" altLang="en-US" sz="1600" dirty="0">
+                <a:rPr lang="ja-JP" altLang="en-US" sz="2000" b="1" dirty="0">
                   <a:solidFill>
                     <a:srgbClr val="FF0000"/>
                   </a:solidFill>
-                  <a:latin typeface="HG正楷書体-PRO" panose="03000600000000000000" pitchFamily="66" charset="-128"/>
-                  <a:ea typeface="HG正楷書体-PRO" panose="03000600000000000000" pitchFamily="66" charset="-128"/>
+                  <a:latin typeface="ＭＳ Ｐ明朝" panose="02020600040205080304" pitchFamily="18" charset="-128"/>
+                  <a:ea typeface="ＭＳ Ｐ明朝" panose="02020600040205080304" pitchFamily="18" charset="-128"/>
                 </a:rPr>
                 <a:t>井</a:t>
               </a:r>
-              <a:endParaRPr kumimoji="1" lang="ja-JP" altLang="en-US" sz="1600" dirty="0">
+              <a:endParaRPr kumimoji="1" lang="ja-JP" altLang="en-US" sz="2000" b="1" dirty="0">
                 <a:solidFill>
                   <a:srgbClr val="FF0000"/>
                 </a:solidFill>
-                <a:latin typeface="HG正楷書体-PRO" panose="03000600000000000000" pitchFamily="66" charset="-128"/>
-                <a:ea typeface="HG正楷書体-PRO" panose="03000600000000000000" pitchFamily="66" charset="-128"/>
+                <a:latin typeface="ＭＳ Ｐ明朝" panose="02020600040205080304" pitchFamily="18" charset="-128"/>
+                <a:ea typeface="ＭＳ Ｐ明朝" panose="02020600040205080304" pitchFamily="18" charset="-128"/>
               </a:endParaRPr>
             </a:p>
           </p:txBody>
         </p:sp>
       </p:grpSp>
+      <p:sp>
+        <p:nvSpPr>
+          <p:cNvPr id="2" name="正方形/長方形 1">
+            <a:extLst>
+              <a:ext uri="{FF2B5EF4-FFF2-40B4-BE49-F238E27FC236}">
+                <a16:creationId xmlns:a16="http://schemas.microsoft.com/office/drawing/2014/main" id="{9E2FD028-1493-A46A-0B1D-082E58C98E63}"/>
+              </a:ext>
+            </a:extLst>
+          </p:cNvPr>
+          <p:cNvSpPr/>
+          <p:nvPr/>
+        </p:nvSpPr>
+        <p:spPr>
+          <a:xfrm>
+            <a:off x="1817511" y="3115733"/>
+            <a:ext cx="4154311" cy="1128889"/>
+          </a:xfrm>
+          <a:prstGeom prst="rect">
+            <a:avLst/>
+          </a:prstGeom>
+          <a:noFill/>
+          <a:ln>
+            <a:noFill/>
+          </a:ln>
+        </p:spPr>
+        <p:style>
+          <a:lnRef idx="2">
+            <a:schemeClr val="accent1">
+              <a:shade val="15000"/>
+            </a:schemeClr>
+          </a:lnRef>
+          <a:fillRef idx="1">
+            <a:schemeClr val="accent1"/>
+          </a:fillRef>
+          <a:effectRef idx="0">
+            <a:schemeClr val="accent1"/>
+          </a:effectRef>
+          <a:fontRef idx="minor">
+            <a:schemeClr val="lt1"/>
+          </a:fontRef>
+        </p:style>
+        <p:txBody>
+          <a:bodyPr rtlCol="0" anchor="ctr"/>
+          <a:lstStyle/>
+          <a:p>
+            <a:pPr algn="ctr"/>
+            <a:r>
+              <a:rPr kumimoji="1" lang="ja-JP" altLang="en-US" sz="2000" dirty="0">
+                <a:solidFill>
+                  <a:schemeClr val="tx1"/>
+                </a:solidFill>
+                <a:latin typeface="ＭＳ Ｐ明朝" panose="02020600040205080304" pitchFamily="18" charset="-128"/>
+                <a:ea typeface="ＭＳ Ｐ明朝" panose="02020600040205080304" pitchFamily="18" charset="-128"/>
+              </a:rPr>
+              <a:t>株式会社サミットシステムサービス</a:t>
+            </a:r>
+          </a:p>
+        </p:txBody>
+      </p:sp>
       <p:grpSp>
         <p:nvGrpSpPr>
           <p:cNvPr id="49" name="グループ化 48">
@@ -4615,7 +4695,7 @@
         </p:nvGrpSpPr>
         <p:grpSpPr>
           <a:xfrm>
-            <a:off x="6458618" y="3074944"/>
+            <a:off x="6537640" y="1031656"/>
             <a:ext cx="708112" cy="708112"/>
             <a:chOff x="649942" y="764723"/>
             <a:chExt cx="708112" cy="708112"/>
@@ -4671,7 +4751,10 @@
             <a:lstStyle/>
             <a:p>
               <a:pPr algn="ctr"/>
-              <a:endParaRPr kumimoji="1" lang="ja-JP" altLang="en-US"/>
+              <a:endParaRPr kumimoji="1" lang="ja-JP" altLang="en-US" sz="2400" b="1">
+                <a:latin typeface="ＭＳ Ｐ明朝" panose="02020600040205080304" pitchFamily="18" charset="-128"/>
+                <a:ea typeface="ＭＳ Ｐ明朝" panose="02020600040205080304" pitchFamily="18" charset="-128"/>
+              </a:endParaRPr>
             </a:p>
           </p:txBody>
         </p:sp>
@@ -4689,8 +4772,8 @@
           </p:nvSpPr>
           <p:spPr>
             <a:xfrm>
-              <a:off x="809073" y="826391"/>
-              <a:ext cx="389850" cy="584775"/>
+              <a:off x="782624" y="764836"/>
+              <a:ext cx="442749" cy="707886"/>
             </a:xfrm>
             <a:prstGeom prst="rect">
               <a:avLst/>
@@ -4705,32 +4788,32 @@
             <a:p>
               <a:pPr algn="ctr"/>
               <a:r>
-                <a:rPr kumimoji="1" lang="ja-JP" altLang="en-US" sz="1600" dirty="0">
+                <a:rPr kumimoji="1" lang="ja-JP" altLang="en-US" sz="2000" b="1" dirty="0">
                   <a:solidFill>
                     <a:srgbClr val="FF0000"/>
                   </a:solidFill>
-                  <a:latin typeface="HG正楷書体-PRO" panose="03000600000000000000" pitchFamily="66" charset="-128"/>
-                  <a:ea typeface="HG正楷書体-PRO" panose="03000600000000000000" pitchFamily="66" charset="-128"/>
+                  <a:latin typeface="ＭＳ Ｐ明朝" panose="02020600040205080304" pitchFamily="18" charset="-128"/>
+                  <a:ea typeface="ＭＳ Ｐ明朝" panose="02020600040205080304" pitchFamily="18" charset="-128"/>
                 </a:rPr>
                 <a:t>時</a:t>
               </a:r>
-              <a:endParaRPr kumimoji="1" lang="en-US" altLang="ja-JP" sz="1600" dirty="0">
+              <a:endParaRPr kumimoji="1" lang="en-US" altLang="ja-JP" sz="2000" b="1" dirty="0">
                 <a:solidFill>
                   <a:srgbClr val="FF0000"/>
                 </a:solidFill>
-                <a:latin typeface="HG正楷書体-PRO" panose="03000600000000000000" pitchFamily="66" charset="-128"/>
-                <a:ea typeface="HG正楷書体-PRO" panose="03000600000000000000" pitchFamily="66" charset="-128"/>
+                <a:latin typeface="ＭＳ Ｐ明朝" panose="02020600040205080304" pitchFamily="18" charset="-128"/>
+                <a:ea typeface="ＭＳ Ｐ明朝" panose="02020600040205080304" pitchFamily="18" charset="-128"/>
               </a:endParaRPr>
             </a:p>
             <a:p>
               <a:pPr algn="ctr"/>
               <a:r>
-                <a:rPr kumimoji="1" lang="ja-JP" altLang="en-US" sz="1600" dirty="0">
+                <a:rPr kumimoji="1" lang="ja-JP" altLang="en-US" sz="2000" b="1" dirty="0">
                   <a:solidFill>
                     <a:srgbClr val="FF0000"/>
                   </a:solidFill>
-                  <a:latin typeface="HG正楷書体-PRO" panose="03000600000000000000" pitchFamily="66" charset="-128"/>
-                  <a:ea typeface="HG正楷書体-PRO" panose="03000600000000000000" pitchFamily="66" charset="-128"/>
+                  <a:latin typeface="ＭＳ Ｐ明朝" panose="02020600040205080304" pitchFamily="18" charset="-128"/>
+                  <a:ea typeface="ＭＳ Ｐ明朝" panose="02020600040205080304" pitchFamily="18" charset="-128"/>
                 </a:rPr>
                 <a:t>尾</a:t>
               </a:r>

</xml_diff>